<commit_message>
renaming ML files to lect_*
</commit_message>
<xml_diff>
--- a/ETL.pptx
+++ b/ETL.pptx
@@ -15811,8 +15811,8 @@
         </p:nvSpPr>
         <p:spPr>
           <a:xfrm>
-            <a:off x="93258" y="-77443"/>
-            <a:ext cx="4625888" cy="457371"/>
+            <a:off x="93257" y="63233"/>
+            <a:ext cx="5580711" cy="457371"/>
           </a:xfrm>
           <a:prstGeom prst="rect">
             <a:avLst/>
@@ -15842,14 +15842,17 @@
                 <a:solidFill>
                   <a:srgbClr val="0070C0"/>
                 </a:solidFill>
-                <a:latin typeface="Calibri"/>
-                <a:ea typeface="Calibri"/>
-                <a:cs typeface="Calibri"/>
+                <a:latin typeface="Arial" panose="020B0604020202020204" pitchFamily="34" charset="0"/>
+                <a:ea typeface="Calibri"/>
+                <a:cs typeface="Arial" panose="020B0604020202020204" pitchFamily="34" charset="0"/>
                 <a:sym typeface="Calibri"/>
               </a:rPr>
               <a:t>ETL – Extract Transform Load</a:t>
             </a:r>
-            <a:endParaRPr dirty="0"/>
+            <a:endParaRPr b="1" dirty="0">
+              <a:latin typeface="Arial" panose="020B0604020202020204" pitchFamily="34" charset="0"/>
+              <a:cs typeface="Arial" panose="020B0604020202020204" pitchFamily="34" charset="0"/>
+            </a:endParaRPr>
           </a:p>
         </p:txBody>
       </p:sp>
@@ -15867,7 +15870,7 @@
         </p:nvSpPr>
         <p:spPr>
           <a:xfrm>
-            <a:off x="151730" y="379928"/>
+            <a:off x="151730" y="520604"/>
             <a:ext cx="4298731" cy="738664"/>
           </a:xfrm>
           <a:prstGeom prst="rect">
@@ -15915,7 +15918,7 @@
         <p:spPr>
           <a:xfrm>
             <a:off x="93258" y="1470982"/>
-            <a:ext cx="2597390" cy="457371"/>
+            <a:ext cx="4356740" cy="457371"/>
           </a:xfrm>
           <a:prstGeom prst="rect">
             <a:avLst/>
@@ -15941,18 +15944,21 @@
               <a:buNone/>
             </a:pPr>
             <a:r>
-              <a:rPr lang="en-US" sz="2800" dirty="0">
+              <a:rPr lang="en-US" sz="2800" b="1" dirty="0">
                 <a:solidFill>
                   <a:srgbClr val="0070C0"/>
                 </a:solidFill>
-                <a:latin typeface="Calibri"/>
-                <a:ea typeface="Calibri"/>
-                <a:cs typeface="Calibri"/>
+                <a:latin typeface="Arial" panose="020B0604020202020204" pitchFamily="34" charset="0"/>
+                <a:ea typeface="Calibri"/>
+                <a:cs typeface="Arial" panose="020B0604020202020204" pitchFamily="34" charset="0"/>
                 <a:sym typeface="Calibri"/>
               </a:rPr>
               <a:t>Good Practices</a:t>
             </a:r>
-            <a:endParaRPr dirty="0"/>
+            <a:endParaRPr b="1" dirty="0">
+              <a:latin typeface="Arial" panose="020B0604020202020204" pitchFamily="34" charset="0"/>
+              <a:cs typeface="Arial" panose="020B0604020202020204" pitchFamily="34" charset="0"/>
+            </a:endParaRPr>
           </a:p>
         </p:txBody>
       </p:sp>

</xml_diff>